<commit_message>
Déploiement: je redeployais le site et le modification du power point
</commit_message>
<xml_diff>
--- a/Docs/MOUHAMED_FALL_Presentation.pptx
+++ b/Docs/MOUHAMED_FALL_Presentation.pptx
@@ -483,7 +483,7 @@
           <a:p>
             <a:fld id="{176D0FA7-4F60-4B4F-BFEF-C92D59061BA6}" type="datetimeFigureOut">
               <a:rPr lang="fr-FR" smtClean="0"/>
-              <a:t>23/06/2026</a:t>
+              <a:t>26/06/2026</a:t>
             </a:fld>
             <a:endParaRPr lang="fr-FR"/>
           </a:p>
@@ -819,7 +819,7 @@
           <a:p>
             <a:fld id="{176D0FA7-4F60-4B4F-BFEF-C92D59061BA6}" type="datetimeFigureOut">
               <a:rPr lang="fr-FR" smtClean="0"/>
-              <a:t>23/06/2026</a:t>
+              <a:t>26/06/2026</a:t>
             </a:fld>
             <a:endParaRPr lang="fr-FR"/>
           </a:p>
@@ -1079,7 +1079,7 @@
           <a:p>
             <a:fld id="{176D0FA7-4F60-4B4F-BFEF-C92D59061BA6}" type="datetimeFigureOut">
               <a:rPr lang="fr-FR" smtClean="0"/>
-              <a:t>23/06/2026</a:t>
+              <a:t>26/06/2026</a:t>
             </a:fld>
             <a:endParaRPr lang="fr-FR"/>
           </a:p>
@@ -1430,7 +1430,7 @@
           <a:p>
             <a:fld id="{176D0FA7-4F60-4B4F-BFEF-C92D59061BA6}" type="datetimeFigureOut">
               <a:rPr lang="fr-FR" smtClean="0"/>
-              <a:t>23/06/2026</a:t>
+              <a:t>26/06/2026</a:t>
             </a:fld>
             <a:endParaRPr lang="fr-FR"/>
           </a:p>
@@ -1789,7 +1789,7 @@
           <a:p>
             <a:fld id="{176D0FA7-4F60-4B4F-BFEF-C92D59061BA6}" type="datetimeFigureOut">
               <a:rPr lang="fr-FR" smtClean="0"/>
-              <a:t>23/06/2026</a:t>
+              <a:t>26/06/2026</a:t>
             </a:fld>
             <a:endParaRPr lang="fr-FR"/>
           </a:p>
@@ -2175,7 +2175,7 @@
           <a:p>
             <a:fld id="{176D0FA7-4F60-4B4F-BFEF-C92D59061BA6}" type="datetimeFigureOut">
               <a:rPr lang="fr-FR" smtClean="0"/>
-              <a:t>23/06/2026</a:t>
+              <a:t>26/06/2026</a:t>
             </a:fld>
             <a:endParaRPr lang="fr-FR"/>
           </a:p>
@@ -2657,7 +2657,7 @@
           <a:p>
             <a:fld id="{176D0FA7-4F60-4B4F-BFEF-C92D59061BA6}" type="datetimeFigureOut">
               <a:rPr lang="fr-FR" smtClean="0"/>
-              <a:t>23/06/2026</a:t>
+              <a:t>26/06/2026</a:t>
             </a:fld>
             <a:endParaRPr lang="fr-FR"/>
           </a:p>
@@ -2874,7 +2874,7 @@
           <a:p>
             <a:fld id="{176D0FA7-4F60-4B4F-BFEF-C92D59061BA6}" type="datetimeFigureOut">
               <a:rPr lang="fr-FR" smtClean="0"/>
-              <a:t>23/06/2026</a:t>
+              <a:t>26/06/2026</a:t>
             </a:fld>
             <a:endParaRPr lang="fr-FR"/>
           </a:p>
@@ -3097,7 +3097,7 @@
           <a:p>
             <a:fld id="{176D0FA7-4F60-4B4F-BFEF-C92D59061BA6}" type="datetimeFigureOut">
               <a:rPr lang="fr-FR" smtClean="0"/>
-              <a:t>23/06/2026</a:t>
+              <a:t>26/06/2026</a:t>
             </a:fld>
             <a:endParaRPr lang="fr-FR"/>
           </a:p>
@@ -3341,7 +3341,7 @@
           <a:p>
             <a:fld id="{176D0FA7-4F60-4B4F-BFEF-C92D59061BA6}" type="datetimeFigureOut">
               <a:rPr lang="fr-FR" smtClean="0"/>
-              <a:t>23/06/2026</a:t>
+              <a:t>26/06/2026</a:t>
             </a:fld>
             <a:endParaRPr lang="fr-FR"/>
           </a:p>
@@ -3601,7 +3601,7 @@
           <a:p>
             <a:fld id="{176D0FA7-4F60-4B4F-BFEF-C92D59061BA6}" type="datetimeFigureOut">
               <a:rPr lang="fr-FR" smtClean="0"/>
-              <a:t>23/06/2026</a:t>
+              <a:t>26/06/2026</a:t>
             </a:fld>
             <a:endParaRPr lang="fr-FR"/>
           </a:p>
@@ -3911,7 +3911,7 @@
           <a:p>
             <a:fld id="{176D0FA7-4F60-4B4F-BFEF-C92D59061BA6}" type="datetimeFigureOut">
               <a:rPr lang="fr-FR" smtClean="0"/>
-              <a:t>23/06/2026</a:t>
+              <a:t>26/06/2026</a:t>
             </a:fld>
             <a:endParaRPr lang="fr-FR"/>
           </a:p>
@@ -4317,7 +4317,7 @@
           <a:p>
             <a:fld id="{176D0FA7-4F60-4B4F-BFEF-C92D59061BA6}" type="datetimeFigureOut">
               <a:rPr lang="fr-FR" smtClean="0"/>
-              <a:t>23/06/2026</a:t>
+              <a:t>26/06/2026</a:t>
             </a:fld>
             <a:endParaRPr lang="fr-FR"/>
           </a:p>
@@ -4478,7 +4478,7 @@
           <a:p>
             <a:fld id="{176D0FA7-4F60-4B4F-BFEF-C92D59061BA6}" type="datetimeFigureOut">
               <a:rPr lang="fr-FR" smtClean="0"/>
-              <a:t>23/06/2026</a:t>
+              <a:t>26/06/2026</a:t>
             </a:fld>
             <a:endParaRPr lang="fr-FR"/>
           </a:p>
@@ -4616,7 +4616,7 @@
           <a:p>
             <a:fld id="{176D0FA7-4F60-4B4F-BFEF-C92D59061BA6}" type="datetimeFigureOut">
               <a:rPr lang="fr-FR" smtClean="0"/>
-              <a:t>23/06/2026</a:t>
+              <a:t>26/06/2026</a:t>
             </a:fld>
             <a:endParaRPr lang="fr-FR"/>
           </a:p>
@@ -4883,7 +4883,7 @@
           <a:p>
             <a:fld id="{176D0FA7-4F60-4B4F-BFEF-C92D59061BA6}" type="datetimeFigureOut">
               <a:rPr lang="fr-FR" smtClean="0"/>
-              <a:t>23/06/2026</a:t>
+              <a:t>26/06/2026</a:t>
             </a:fld>
             <a:endParaRPr lang="fr-FR"/>
           </a:p>
@@ -5210,7 +5210,7 @@
           <a:p>
             <a:fld id="{176D0FA7-4F60-4B4F-BFEF-C92D59061BA6}" type="datetimeFigureOut">
               <a:rPr lang="fr-FR" smtClean="0"/>
-              <a:t>23/06/2026</a:t>
+              <a:t>26/06/2026</a:t>
             </a:fld>
             <a:endParaRPr lang="fr-FR"/>
           </a:p>
@@ -5605,7 +5605,7 @@
           <a:p>
             <a:fld id="{176D0FA7-4F60-4B4F-BFEF-C92D59061BA6}" type="datetimeFigureOut">
               <a:rPr lang="fr-FR" smtClean="0"/>
-              <a:t>23/06/2026</a:t>
+              <a:t>26/06/2026</a:t>
             </a:fld>
             <a:endParaRPr lang="fr-FR"/>
           </a:p>
@@ -6386,7 +6386,6 @@
               <a:rPr lang="fr-FR" dirty="0" smtClean="0"/>
               <a:t>du git  </a:t>
             </a:r>
-            <a:endParaRPr lang="fr-FR" dirty="0" smtClean="0"/>
           </a:p>
           <a:p>
             <a:endParaRPr lang="fr-FR" dirty="0"/>
@@ -6851,11 +6850,7 @@
             </a:r>
             <a:r>
               <a:rPr lang="en-US" dirty="0" smtClean="0"/>
-              <a:t> techniques. </a:t>
-            </a:r>
-            <a:r>
-              <a:rPr lang="en-US" dirty="0" smtClean="0"/>
-              <a:t>Et pour </a:t>
+              <a:t> techniques. Et pour </a:t>
             </a:r>
             <a:r>
               <a:rPr lang="en-US" dirty="0" err="1" smtClean="0"/>
@@ -7065,11 +7060,7 @@
           <a:p>
             <a:r>
               <a:rPr lang="en-US" dirty="0" smtClean="0"/>
-              <a:t>DOCUMENTATION </a:t>
-            </a:r>
-            <a:r>
-              <a:rPr lang="en-US" dirty="0" smtClean="0"/>
-              <a:t>(MDN </a:t>
+              <a:t>DOCUMENTATION (MDN </a:t>
             </a:r>
             <a:r>
               <a:rPr lang="en-US" dirty="0"/>
@@ -7080,11 +7071,7 @@
           <a:p>
             <a:r>
               <a:rPr lang="en-US" dirty="0" smtClean="0"/>
-              <a:t>OUTILS</a:t>
-            </a:r>
-            <a:r>
-              <a:rPr lang="en-US" dirty="0" smtClean="0"/>
-              <a:t>( v</a:t>
+              <a:t>OUTILS( v</a:t>
             </a:r>
             <a:r>
               <a:rPr lang="fr-FR" dirty="0" err="1"/>
@@ -7214,25 +7201,21 @@
           <a:lstStyle/>
           <a:p>
             <a:r>
-              <a:rPr lang="en-US" dirty="0" err="1" smtClean="0"/>
+              <a:rPr lang="en-US" b="1" dirty="0" err="1" smtClean="0"/>
               <a:t>Fonctionnalites</a:t>
             </a:r>
             <a:r>
-              <a:rPr lang="en-US" dirty="0" smtClean="0"/>
-              <a:t> a </a:t>
-            </a:r>
-            <a:r>
-              <a:rPr lang="en-US" dirty="0" smtClean="0"/>
-              <a:t>presenter</a:t>
-            </a:r>
-          </a:p>
-          <a:p>
-            <a:r>
-              <a:rPr lang="fr-FR" dirty="0"/>
+              <a:rPr lang="en-US" b="1" dirty="0" smtClean="0"/>
+              <a:t> a presenter</a:t>
+            </a:r>
+          </a:p>
+          <a:p>
+            <a:r>
+              <a:rPr lang="fr-FR" b="1" dirty="0"/>
               <a:t>La </a:t>
             </a:r>
             <a:r>
-              <a:rPr lang="fr-FR" dirty="0" err="1" smtClean="0"/>
+              <a:rPr lang="fr-FR" b="1" dirty="0" err="1" smtClean="0"/>
               <a:t>Homepage</a:t>
             </a:r>
             <a:r>
@@ -7270,8 +7253,12 @@
           </a:p>
           <a:p>
             <a:r>
+              <a:rPr lang="fr-FR" b="1" dirty="0"/>
+              <a:t>L'Expérience Utilisateur </a:t>
+            </a:r>
+            <a:r>
               <a:rPr lang="fr-FR" dirty="0"/>
-              <a:t>L'Expérience Utilisateur (Le Mode Sombre</a:t>
+              <a:t>(Le Mode Sombre</a:t>
             </a:r>
             <a:r>
               <a:rPr lang="fr-FR" dirty="0" smtClean="0"/>
@@ -7296,8 +7283,12 @@
           </a:p>
           <a:p>
             <a:r>
+              <a:rPr lang="fr-FR" b="1" dirty="0"/>
+              <a:t>L'Exploration</a:t>
+            </a:r>
+            <a:r>
               <a:rPr lang="fr-FR" dirty="0"/>
-              <a:t>L'Exploration (Le Catalogue &amp; Structure Bento</a:t>
+              <a:t> (Le Catalogue &amp; Structure Bento</a:t>
             </a:r>
             <a:r>
               <a:rPr lang="fr-FR" dirty="0" smtClean="0"/>
@@ -7731,7 +7722,6 @@
               <a:rPr lang="fr-FR" dirty="0"/>
               <a:t>Nouvelles Fonctionnalités (Back-End &amp; Expérience Utilisateur)</a:t>
             </a:r>
-            <a:endParaRPr lang="fr-FR" dirty="0"/>
           </a:p>
         </p:txBody>
       </p:sp>
@@ -7786,189 +7776,81 @@
       </p:grpSpPr>
       <p:sp>
         <p:nvSpPr>
-          <p:cNvPr id="5" name="Rectangle 4"/>
-          <p:cNvSpPr/>
-          <p:nvPr/>
-        </p:nvSpPr>
-        <p:spPr>
-          <a:xfrm>
-            <a:off x="868680" y="914400"/>
-            <a:ext cx="10538460" cy="4801314"/>
-          </a:xfrm>
-          <a:prstGeom prst="rect">
-            <a:avLst/>
-          </a:prstGeom>
-        </p:spPr>
-        <p:txBody>
-          <a:bodyPr wrap="square">
-            <a:spAutoFit/>
-          </a:bodyPr>
-          <a:lstStyle/>
-          <a:p>
-            <a:r>
-              <a:rPr lang="fr-FR" dirty="0"/>
-              <a:t>La Conclusion (Le Bilan du Projet)C'est le moment de rappeler le succès de la phase initiale de </a:t>
-            </a:r>
-            <a:r>
-              <a:rPr lang="fr-FR" dirty="0" err="1"/>
-              <a:t>développement.Compétences</a:t>
-            </a:r>
-            <a:r>
-              <a:rPr lang="fr-FR" dirty="0"/>
-              <a:t> validées : Maîtrise des technologies front-end modernes (intégration complète de </a:t>
-            </a:r>
-            <a:r>
-              <a:rPr lang="fr-FR" dirty="0" err="1"/>
-              <a:t>Bootstrap</a:t>
-            </a:r>
-            <a:r>
-              <a:rPr lang="fr-FR" dirty="0"/>
-              <a:t> 5, création de </a:t>
-            </a:r>
-            <a:r>
-              <a:rPr lang="fr-FR" dirty="0" err="1"/>
-              <a:t>layouts</a:t>
-            </a:r>
-            <a:r>
-              <a:rPr lang="fr-FR" dirty="0"/>
-              <a:t> asymétriques en CSS </a:t>
-            </a:r>
-            <a:r>
-              <a:rPr lang="fr-FR" dirty="0" err="1"/>
-              <a:t>Grid</a:t>
-            </a:r>
-            <a:r>
-              <a:rPr lang="fr-FR" dirty="0"/>
-              <a:t> / Bento </a:t>
-            </a:r>
-            <a:r>
-              <a:rPr lang="fr-FR" dirty="0" err="1"/>
-              <a:t>Layout</a:t>
-            </a:r>
-            <a:r>
-              <a:rPr lang="fr-FR" dirty="0"/>
-              <a:t>, et développement de fonctionnalités dynamiques en JavaScript).Objectif atteint : Création d'une interface utilisateur (UI) soignée, respectant les standards de design actuels (thème sombre technique, </a:t>
-            </a:r>
-            <a:r>
-              <a:rPr lang="fr-FR" dirty="0" err="1"/>
-              <a:t>glassmorphism</a:t>
-            </a:r>
-            <a:r>
-              <a:rPr lang="fr-FR" dirty="0"/>
-              <a:t>), entièrement responsive et déployée de manière fonctionnelle sur GitHub Pages.2. Les Perspectives d'Amélioration (La Vision d'Avenir)Montrez au jury que vous pensez comme un vrai développeur en proposant des évolutions logiques pour transformer ce site vitrine en une application web complète (</a:t>
-            </a:r>
-            <a:r>
-              <a:rPr lang="fr-FR" dirty="0" err="1"/>
-              <a:t>SaaS</a:t>
-            </a:r>
-            <a:r>
-              <a:rPr lang="fr-FR" dirty="0"/>
-              <a:t> / Marketplace).🛠️ Améliorations Techniques (Front-End &amp; Performance)Transition vers un </a:t>
-            </a:r>
-            <a:r>
-              <a:rPr lang="fr-FR" dirty="0" err="1"/>
-              <a:t>framework</a:t>
-            </a:r>
-            <a:r>
-              <a:rPr lang="fr-FR" dirty="0"/>
-              <a:t> moderne : Migrer le code HTML/JS classique vers </a:t>
-            </a:r>
-            <a:r>
-              <a:rPr lang="fr-FR" dirty="0" err="1"/>
-              <a:t>React</a:t>
-            </a:r>
-            <a:r>
-              <a:rPr lang="fr-FR" dirty="0"/>
-              <a:t> ou Vue.js pour créer une application à page unique (SPA) plus robuste et </a:t>
-            </a:r>
-            <a:r>
-              <a:rPr lang="fr-FR" dirty="0" err="1"/>
-              <a:t>modulaire.Optimisation</a:t>
-            </a:r>
-            <a:r>
-              <a:rPr lang="fr-FR" dirty="0"/>
-              <a:t> avancée (SEO &amp; Vitesse) : Compresser les images au format .</a:t>
-            </a:r>
-            <a:r>
-              <a:rPr lang="fr-FR" dirty="0" err="1"/>
-              <a:t>webp</a:t>
-            </a:r>
-            <a:r>
-              <a:rPr lang="fr-FR" dirty="0"/>
-              <a:t> pour améliorer les temps de chargement et peaufiner les balises </a:t>
-            </a:r>
-            <a:r>
-              <a:rPr lang="fr-FR" dirty="0" err="1"/>
-              <a:t>meta</a:t>
-            </a:r>
-            <a:r>
-              <a:rPr lang="fr-FR" dirty="0"/>
-              <a:t> pour le référencement.💼 Nouvelles Fonctionnalités (Back-End &amp; Expérience Utilisateur)Système d'authentification : Intégrer un </a:t>
-            </a:r>
-            <a:r>
-              <a:rPr lang="fr-FR" dirty="0" err="1"/>
-              <a:t>backend</a:t>
-            </a:r>
-            <a:r>
-              <a:rPr lang="fr-FR" dirty="0"/>
-              <a:t> (Node.js, </a:t>
-            </a:r>
-            <a:r>
-              <a:rPr lang="fr-FR" dirty="0" err="1"/>
-              <a:t>Firebase</a:t>
-            </a:r>
-            <a:r>
-              <a:rPr lang="fr-FR" dirty="0"/>
-              <a:t> ou </a:t>
-            </a:r>
-            <a:r>
-              <a:rPr lang="fr-FR" dirty="0" err="1"/>
-              <a:t>Supabase</a:t>
-            </a:r>
-            <a:r>
-              <a:rPr lang="fr-FR" dirty="0"/>
-              <a:t>) pour permettre aux freelances de s'inscrire, de créer et de modifier eux-mêmes leur </a:t>
-            </a:r>
-            <a:r>
-              <a:rPr lang="fr-FR" dirty="0" err="1"/>
-              <a:t>profil.Barre</a:t>
-            </a:r>
-            <a:r>
-              <a:rPr lang="fr-FR" dirty="0"/>
-              <a:t> de recherche dynamique &amp; Filtres réels : Connecter une base de données (comme PostgreSQL ou </a:t>
-            </a:r>
-            <a:r>
-              <a:rPr lang="fr-FR" dirty="0" err="1"/>
-              <a:t>MongoDB</a:t>
-            </a:r>
-            <a:r>
-              <a:rPr lang="fr-FR" dirty="0"/>
-              <a:t>) pour que la recherche par compétences, tarifs ou pays s'exécute instantanément côté </a:t>
-            </a:r>
-            <a:r>
-              <a:rPr lang="fr-FR" dirty="0" err="1"/>
-              <a:t>serveur.Messagerie</a:t>
-            </a:r>
-            <a:r>
-              <a:rPr lang="fr-FR" dirty="0"/>
-              <a:t> interne et Paiement sécurisé : Planifier l'intégration de l'API </a:t>
-            </a:r>
-            <a:r>
-              <a:rPr lang="fr-FR" dirty="0" err="1"/>
-              <a:t>Stripe</a:t>
-            </a:r>
-            <a:r>
-              <a:rPr lang="fr-FR" dirty="0"/>
-              <a:t> pour sécuriser les transactions entre les entreprises et les talents, et ajouter un chat en temps réel (</a:t>
-            </a:r>
-            <a:r>
-              <a:rPr lang="fr-FR" dirty="0" err="1"/>
-              <a:t>WebSockets</a:t>
-            </a:r>
-            <a:r>
-              <a:rPr lang="fr-FR" dirty="0"/>
-              <a:t>).</a:t>
-            </a:r>
+          <p:cNvPr id="2" name="Titre 1"/>
+          <p:cNvSpPr>
+            <a:spLocks noGrp="1"/>
+          </p:cNvSpPr>
+          <p:nvPr>
+            <p:ph type="ctrTitle"/>
+          </p:nvPr>
+        </p:nvSpPr>
+        <p:spPr/>
+        <p:txBody>
+          <a:bodyPr/>
+          <a:lstStyle/>
+          <a:p>
+            <a:r>
+              <a:rPr lang="en-US" sz="8000" b="1" dirty="0" smtClean="0">
+                <a:latin typeface="Algerian" panose="04020705040A02060702" pitchFamily="82" charset="0"/>
+              </a:rPr>
+              <a:t>MERCI !</a:t>
+            </a:r>
+            <a:endParaRPr lang="fr-FR" sz="8000" b="1" dirty="0">
+              <a:latin typeface="Algerian" panose="04020705040A02060702" pitchFamily="82" charset="0"/>
+            </a:endParaRPr>
+          </a:p>
+        </p:txBody>
+      </p:sp>
+      <p:sp>
+        <p:nvSpPr>
+          <p:cNvPr id="3" name="Sous-titre 2"/>
+          <p:cNvSpPr>
+            <a:spLocks noGrp="1"/>
+          </p:cNvSpPr>
+          <p:nvPr>
+            <p:ph type="subTitle" idx="1"/>
+          </p:nvPr>
+        </p:nvSpPr>
+        <p:spPr/>
+        <p:txBody>
+          <a:bodyPr/>
+          <a:lstStyle/>
+          <a:p>
+            <a:r>
+              <a:rPr lang="en-US" sz="2800" b="1" i="1" dirty="0">
+                <a:latin typeface="Algerian" panose="04020705040A02060702" pitchFamily="82" charset="0"/>
+                <a:cs typeface="Calibri Light" panose="020F0302020204030204" pitchFamily="34" charset="0"/>
+              </a:rPr>
+              <a:t>Plus grand </a:t>
+            </a:r>
+            <a:r>
+              <a:rPr lang="en-US" sz="2800" b="1" i="1" dirty="0" err="1">
+                <a:latin typeface="Algerian" panose="04020705040A02060702" pitchFamily="82" charset="0"/>
+                <a:cs typeface="Calibri Light" panose="020F0302020204030204" pitchFamily="34" charset="0"/>
+              </a:rPr>
+              <a:t>est</a:t>
+            </a:r>
+            <a:r>
+              <a:rPr lang="en-US" sz="2800" b="1" i="1" dirty="0">
+                <a:latin typeface="Algerian" panose="04020705040A02060702" pitchFamily="82" charset="0"/>
+                <a:cs typeface="Calibri Light" panose="020F0302020204030204" pitchFamily="34" charset="0"/>
+              </a:rPr>
+              <a:t> ton combat , plus sera ta </a:t>
+            </a:r>
+            <a:r>
+              <a:rPr lang="en-US" sz="2800" b="1" i="1" dirty="0" err="1">
+                <a:latin typeface="Algerian" panose="04020705040A02060702" pitchFamily="82" charset="0"/>
+                <a:cs typeface="Calibri Light" panose="020F0302020204030204" pitchFamily="34" charset="0"/>
+              </a:rPr>
+              <a:t>victoire</a:t>
+            </a:r>
+            <a:endParaRPr lang="fr-FR" sz="2800" b="1" i="1" dirty="0">
+              <a:latin typeface="Algerian" panose="04020705040A02060702" pitchFamily="82" charset="0"/>
+              <a:cs typeface="Calibri Light" panose="020F0302020204030204" pitchFamily="34" charset="0"/>
+            </a:endParaRPr>
+          </a:p>
+          <a:p>
+            <a:endParaRPr lang="fr-FR" dirty="0"/>
           </a:p>
         </p:txBody>
       </p:sp>
@@ -8300,7 +8182,7 @@
         <p:spPr/>
         <p:txBody>
           <a:bodyPr>
-            <a:normAutofit fontScale="77500" lnSpcReduction="20000"/>
+            <a:normAutofit fontScale="92500"/>
           </a:bodyPr>
           <a:lstStyle/>
           <a:p>
@@ -8322,19 +8204,7 @@
             </a:r>
             <a:r>
               <a:rPr lang="fr-FR" sz="2800" dirty="0"/>
-              <a:t>en Afrique connaît une croissance explosive. De plus en plus de développeurs, de designers et de créateurs de contenu ont besoin d'une plateforme fiable pour proposer leurs services. Parallèlement, les entreprises cherchent à simplifier leur recherche de compétences qualifiées</a:t>
-            </a:r>
-            <a:r>
-              <a:rPr lang="fr-FR" sz="2800" dirty="0" smtClean="0"/>
-              <a:t>. La conception d’</a:t>
-            </a:r>
-            <a:r>
-              <a:rPr lang="fr-FR" sz="2800" dirty="0" err="1" smtClean="0"/>
-              <a:t>Afritalent</a:t>
-            </a:r>
-            <a:r>
-              <a:rPr lang="fr-FR" sz="2800" dirty="0" smtClean="0"/>
-              <a:t> , une site vitrine moderne et interactif servant de ont entre ces deux acteurs</a:t>
+              <a:t>en Afrique connaît une croissance explosive. De plus en plus de développeurs, de designers et de créateurs de contenu ont besoin d'une plateforme fiable pour proposer leurs services. </a:t>
             </a:r>
             <a:endParaRPr lang="fr-FR" sz="2800" b="1" dirty="0" smtClean="0"/>
           </a:p>
@@ -8607,8 +8477,8 @@
         </p:nvSpPr>
         <p:spPr>
           <a:xfrm>
-            <a:off x="742950" y="904875"/>
-            <a:ext cx="10801350" cy="5170646"/>
+            <a:off x="790575" y="1943100"/>
+            <a:ext cx="10801350" cy="2677656"/>
           </a:xfrm>
           <a:prstGeom prst="rect">
             <a:avLst/>
@@ -8626,62 +8496,92 @@
             </a:r>
             <a:r>
               <a:rPr lang="fr-FR" sz="2200" b="1" dirty="0"/>
-              <a:t> :</a:t>
-            </a:r>
-            <a:r>
-              <a:rPr lang="fr-FR" sz="2200" dirty="0"/>
-              <a:t>Une identité forte centrée sur la carte de l'Afrique pour affirmer l'ancrage continental et tendances web de 2026, épurées et asymétriques. L'identité visuelle d'</a:t>
-            </a:r>
-            <a:r>
-              <a:rPr lang="fr-FR" sz="2200" dirty="0" err="1"/>
+              <a:t> </a:t>
+            </a:r>
+            <a:r>
+              <a:rPr lang="fr-FR" sz="2200" b="1" dirty="0" smtClean="0"/>
+              <a:t>:</a:t>
+            </a:r>
+            <a:r>
+              <a:rPr lang="fr-FR" sz="2400" dirty="0"/>
+              <a:t>L'identité visuelle d'</a:t>
+            </a:r>
+            <a:r>
+              <a:rPr lang="fr-FR" sz="2400" dirty="0" err="1"/>
               <a:t>AfriTalent</a:t>
             </a:r>
             <a:r>
-              <a:rPr lang="fr-FR" sz="2200" dirty="0"/>
-              <a:t> 2026 est conçue comme un pont esthétique reliant la rigueur de l'ingénierie </a:t>
-            </a:r>
-            <a:r>
-              <a:rPr lang="fr-FR" sz="2200" dirty="0" err="1"/>
+              <a:rPr lang="fr-FR" sz="2400" dirty="0"/>
+              <a:t> 2026 affirme son ancrage continental à travers un design épuré, asymétrique et moderne, structuré par une </a:t>
+            </a:r>
+            <a:r>
+              <a:rPr lang="fr-FR" sz="2400" i="1" dirty="0"/>
+              <a:t>Bento </a:t>
+            </a:r>
+            <a:r>
+              <a:rPr lang="fr-FR" sz="2400" i="1" dirty="0" err="1"/>
+              <a:t>Grid</a:t>
+            </a:r>
+            <a:r>
+              <a:rPr lang="fr-FR" sz="2400" dirty="0"/>
+              <a:t> de haute précision. Elle marie la rigueur technologique à l'énergie africaine en associant le </a:t>
+            </a:r>
+            <a:r>
+              <a:rPr lang="fr-FR" sz="2400" b="1" dirty="0"/>
+              <a:t>Bleu Abyssal</a:t>
+            </a:r>
+            <a:r>
+              <a:rPr lang="fr-FR" sz="2400" dirty="0"/>
+              <a:t> (stabilité) à l'</a:t>
+            </a:r>
+            <a:r>
+              <a:rPr lang="fr-FR" sz="2400" b="1" dirty="0"/>
+              <a:t>Orange Safari</a:t>
+            </a:r>
+            <a:r>
+              <a:rPr lang="fr-FR" sz="2400" dirty="0"/>
+              <a:t> (dynamisme), le tout contrasté sur des fonds </a:t>
+            </a:r>
+            <a:r>
+              <a:rPr lang="fr-FR" sz="2400" b="1" dirty="0"/>
+              <a:t>Blanc Craie</a:t>
+            </a:r>
+            <a:r>
+              <a:rPr lang="fr-FR" sz="2400" dirty="0"/>
+              <a:t> ou </a:t>
+            </a:r>
+            <a:r>
+              <a:rPr lang="fr-FR" sz="2400" b="1" dirty="0"/>
+              <a:t>Noir Carbone</a:t>
+            </a:r>
+            <a:r>
+              <a:rPr lang="fr-FR" sz="2400" dirty="0"/>
+              <a:t> (mode nuit). Portée par les typographies </a:t>
+            </a:r>
+            <a:r>
+              <a:rPr lang="fr-FR" sz="2400" i="1" dirty="0"/>
+              <a:t>Plus Jakarta Sans</a:t>
+            </a:r>
+            <a:r>
+              <a:rPr lang="fr-FR" sz="2400" dirty="0"/>
+              <a:t> et </a:t>
+            </a:r>
+            <a:r>
+              <a:rPr lang="fr-FR" sz="2400" i="1" dirty="0"/>
+              <a:t>Inter</a:t>
+            </a:r>
+            <a:r>
+              <a:rPr lang="fr-FR" sz="2400" dirty="0"/>
+              <a:t>, l'interface offre une expérience immersive et lisible, symbolisant la nouvelle ère de l'excellence </a:t>
+            </a:r>
+            <a:r>
+              <a:rPr lang="fr-FR" sz="2400" dirty="0" err="1"/>
               <a:t>tech</a:t>
             </a:r>
             <a:r>
-              <a:rPr lang="fr-FR" sz="2200" dirty="0"/>
-              <a:t> internationale à l'énergie vibrante et créative du continent africain. En mariant la profondeur structurante du Bleu Abyssal, symbole de stabilité et de confiance professionnelle, à l'élan audacieux de l'Orange Safari qui évoque l'action et le dynamisme, la plateforme installe d'emblée une atmosphère d'innovation et de progrès. Cette tension créative s'équilibre harmonieusement sur un fond épuré oscillant entre la clarté du Blanc Craie et l'intensité moderne du Noir Carbone pour le mode nuit, structuré par une Bento </a:t>
-            </a:r>
-            <a:r>
-              <a:rPr lang="fr-FR" sz="2200" dirty="0" err="1"/>
-              <a:t>Grid</a:t>
-            </a:r>
-            <a:r>
-              <a:rPr lang="fr-FR" sz="2200" dirty="0"/>
-              <a:t> aux bordures Gris Acier d'une précision millimétrique. Portée par la typographie géométrique et ambitieuse </a:t>
-            </a:r>
-            <a:r>
-              <a:rPr lang="fr-FR" sz="2200" i="1" dirty="0"/>
-              <a:t>Plus Jakarta Sans</a:t>
-            </a:r>
-            <a:r>
-              <a:rPr lang="fr-FR" sz="2200" dirty="0"/>
-              <a:t> pour ses titres et la neutralité fonctionnelle de la police </a:t>
-            </a:r>
-            <a:r>
-              <a:rPr lang="fr-FR" sz="2200" i="1" dirty="0"/>
-              <a:t>Inter</a:t>
-            </a:r>
-            <a:r>
-              <a:rPr lang="fr-FR" sz="2200" dirty="0"/>
-              <a:t> pour ses contenus, l'interface offre une lisibilité irréprochable et un confort de lecture universel. </a:t>
-            </a:r>
-            <a:r>
-              <a:rPr lang="fr-FR" sz="2200" dirty="0" err="1"/>
-              <a:t>AfriTalent</a:t>
-            </a:r>
-            <a:r>
-              <a:rPr lang="fr-FR" sz="2200" dirty="0"/>
-              <a:t> ne se contente pas d'aligner des profils, elle orchestre une expérience visuelle immersive et mémorable qui donne corps à la nouvelle ère de l'excellence technologique africaine.</a:t>
-            </a:r>
-          </a:p>
-          <a:p>
+              <a:rPr lang="fr-FR" sz="2400" dirty="0"/>
+              <a:t> en Afrique.</a:t>
+            </a:r>
             <a:endParaRPr lang="en-US" sz="2200" b="1" dirty="0"/>
           </a:p>
         </p:txBody>
@@ -9408,7 +9308,6 @@
               <a:rPr lang="fr-FR" dirty="0" smtClean="0"/>
               <a:t> </a:t>
             </a:r>
-            <a:endParaRPr lang="fr-FR" dirty="0" smtClean="0"/>
           </a:p>
           <a:p>
             <a:r>
@@ -9479,7 +9378,6 @@
               <a:rPr lang="fr-FR" dirty="0" smtClean="0"/>
               <a:t> , les badges , et les composants dynamiques </a:t>
             </a:r>
-            <a:endParaRPr lang="fr-FR" dirty="0" smtClean="0"/>
           </a:p>
           <a:p>
             <a:r>

</xml_diff>